<commit_message>
ref rot e ross
</commit_message>
<xml_diff>
--- a/DISSERTACAO/figuras/figures.pptx
+++ b/DISSERTACAO/figuras/figures.pptx
@@ -5,7 +5,7 @@
     <p:sldMasterId id="2147483648" r:id="rId1"/>
   </p:sldMasterIdLst>
   <p:notesMasterIdLst>
-    <p:notesMasterId r:id="rId11"/>
+    <p:notesMasterId r:id="rId12"/>
   </p:notesMasterIdLst>
   <p:sldIdLst>
     <p:sldId id="256" r:id="rId2"/>
@@ -17,6 +17,7 @@
     <p:sldId id="262" r:id="rId8"/>
     <p:sldId id="263" r:id="rId9"/>
     <p:sldId id="264" r:id="rId10"/>
+    <p:sldId id="265" r:id="rId11"/>
   </p:sldIdLst>
   <p:sldSz cx="12192000" cy="6858000"/>
   <p:notesSz cx="6858000" cy="9144000"/>
@@ -126,7 +127,7 @@
 <file path=ppt/revisionInfo.xml><?xml version="1.0" encoding="utf-8"?>
 <p1510:revInfo xmlns:a="http://schemas.openxmlformats.org/drawingml/2006/main" xmlns:r="http://schemas.openxmlformats.org/officeDocument/2006/relationships" xmlns:p1510="http://schemas.microsoft.com/office/powerpoint/2015/10/main">
   <p1510:revLst>
-    <p1510:client id="{93B72BAE-AB54-495B-86A9-4541991303FD}" v="13" dt="2026-06-02T12:41:21.301"/>
+    <p1510:client id="{93B72BAE-AB54-495B-86A9-4541991303FD}" v="22" dt="2026-06-02T18:19:11.810"/>
   </p1510:revLst>
 </p1510:revInfo>
 </file>
@@ -136,7 +137,7 @@
   <pc:docChgLst>
     <pc:chgData name="Murillo Álvaro Borges de Sousa" userId="02386067-c46f-46e6-bf61-8f6a774af0e5" providerId="ADAL" clId="{73C3FE35-BF7E-418C-A7F8-FA0AB4F63A6B}"/>
     <pc:docChg chg="undo custSel addSld modSld sldOrd">
-      <pc:chgData name="Murillo Álvaro Borges de Sousa" userId="02386067-c46f-46e6-bf61-8f6a774af0e5" providerId="ADAL" clId="{73C3FE35-BF7E-418C-A7F8-FA0AB4F63A6B}" dt="2026-06-02T14:37:18.113" v="359" actId="478"/>
+      <pc:chgData name="Murillo Álvaro Borges de Sousa" userId="02386067-c46f-46e6-bf61-8f6a774af0e5" providerId="ADAL" clId="{73C3FE35-BF7E-418C-A7F8-FA0AB4F63A6B}" dt="2026-06-02T18:19:11.810" v="442" actId="164"/>
       <pc:docMkLst>
         <pc:docMk/>
       </pc:docMkLst>
@@ -856,7 +857,7 @@
         </pc:grpChg>
       </pc:sldChg>
       <pc:sldChg chg="addSp delSp modSp new mod">
-        <pc:chgData name="Murillo Álvaro Borges de Sousa" userId="02386067-c46f-46e6-bf61-8f6a774af0e5" providerId="ADAL" clId="{73C3FE35-BF7E-418C-A7F8-FA0AB4F63A6B}" dt="2026-06-02T14:37:18.113" v="359" actId="478"/>
+        <pc:chgData name="Murillo Álvaro Borges de Sousa" userId="02386067-c46f-46e6-bf61-8f6a774af0e5" providerId="ADAL" clId="{73C3FE35-BF7E-418C-A7F8-FA0AB4F63A6B}" dt="2026-06-02T17:04:50.653" v="374" actId="208"/>
         <pc:sldMkLst>
           <pc:docMk/>
           <pc:sldMk cId="1522299716" sldId="264"/>
@@ -893,12 +894,28 @@
             <ac:spMk id="8" creationId="{847CC85F-1B1D-54D3-04B1-F79DCF1CC49E}"/>
           </ac:spMkLst>
         </pc:spChg>
+        <pc:spChg chg="add mod ord">
+          <ac:chgData name="Murillo Álvaro Borges de Sousa" userId="02386067-c46f-46e6-bf61-8f6a774af0e5" providerId="ADAL" clId="{73C3FE35-BF7E-418C-A7F8-FA0AB4F63A6B}" dt="2026-06-02T17:04:50.653" v="374" actId="208"/>
+          <ac:spMkLst>
+            <pc:docMk/>
+            <pc:sldMk cId="1522299716" sldId="264"/>
+            <ac:spMk id="9" creationId="{E6CBC1F0-97FD-DA72-ED5A-E7D463CC8A68}"/>
+          </ac:spMkLst>
+        </pc:spChg>
         <pc:grpChg chg="add mod">
-          <ac:chgData name="Murillo Álvaro Borges de Sousa" userId="02386067-c46f-46e6-bf61-8f6a774af0e5" providerId="ADAL" clId="{73C3FE35-BF7E-418C-A7F8-FA0AB4F63A6B}" dt="2026-06-02T12:41:21.300" v="354" actId="164"/>
+          <ac:chgData name="Murillo Álvaro Borges de Sousa" userId="02386067-c46f-46e6-bf61-8f6a774af0e5" providerId="ADAL" clId="{73C3FE35-BF7E-418C-A7F8-FA0AB4F63A6B}" dt="2026-06-02T17:04:41.292" v="372" actId="164"/>
           <ac:grpSpMkLst>
             <pc:docMk/>
             <pc:sldMk cId="1522299716" sldId="264"/>
             <ac:grpSpMk id="7" creationId="{1F7C3375-1F11-3A99-DAFF-60594AFA7427}"/>
+          </ac:grpSpMkLst>
+        </pc:grpChg>
+        <pc:grpChg chg="add mod">
+          <ac:chgData name="Murillo Álvaro Borges de Sousa" userId="02386067-c46f-46e6-bf61-8f6a774af0e5" providerId="ADAL" clId="{73C3FE35-BF7E-418C-A7F8-FA0AB4F63A6B}" dt="2026-06-02T17:04:41.292" v="372" actId="164"/>
+          <ac:grpSpMkLst>
+            <pc:docMk/>
+            <pc:sldMk cId="1522299716" sldId="264"/>
+            <ac:grpSpMk id="10" creationId="{FE3EBD89-0E68-3B35-525E-3ABD8515678D}"/>
           </ac:grpSpMkLst>
         </pc:grpChg>
         <pc:picChg chg="add mod">
@@ -909,6 +926,149 @@
             <ac:picMk id="3" creationId="{C395F624-29E7-EB8D-AA14-ACD11D1DD967}"/>
           </ac:picMkLst>
         </pc:picChg>
+      </pc:sldChg>
+      <pc:sldChg chg="addSp delSp modSp new mod">
+        <pc:chgData name="Murillo Álvaro Borges de Sousa" userId="02386067-c46f-46e6-bf61-8f6a774af0e5" providerId="ADAL" clId="{73C3FE35-BF7E-418C-A7F8-FA0AB4F63A6B}" dt="2026-06-02T18:19:11.810" v="442" actId="164"/>
+        <pc:sldMkLst>
+          <pc:docMk/>
+          <pc:sldMk cId="4196720484" sldId="265"/>
+        </pc:sldMkLst>
+        <pc:spChg chg="add del mod">
+          <ac:chgData name="Murillo Álvaro Borges de Sousa" userId="02386067-c46f-46e6-bf61-8f6a774af0e5" providerId="ADAL" clId="{73C3FE35-BF7E-418C-A7F8-FA0AB4F63A6B}" dt="2026-06-02T18:11:23.386" v="379" actId="478"/>
+          <ac:spMkLst>
+            <pc:docMk/>
+            <pc:sldMk cId="4196720484" sldId="265"/>
+            <ac:spMk id="2" creationId="{DEC84091-BDE2-80FA-FCC9-86173490AD77}"/>
+          </ac:spMkLst>
+        </pc:spChg>
+        <pc:spChg chg="add mod">
+          <ac:chgData name="Murillo Álvaro Borges de Sousa" userId="02386067-c46f-46e6-bf61-8f6a774af0e5" providerId="ADAL" clId="{73C3FE35-BF7E-418C-A7F8-FA0AB4F63A6B}" dt="2026-06-02T18:19:05.993" v="441" actId="164"/>
+          <ac:spMkLst>
+            <pc:docMk/>
+            <pc:sldMk cId="4196720484" sldId="265"/>
+            <ac:spMk id="3" creationId="{4D6B3DB7-F0C9-6D0A-542E-1958730A76AF}"/>
+          </ac:spMkLst>
+        </pc:spChg>
+        <pc:spChg chg="add mod">
+          <ac:chgData name="Murillo Álvaro Borges de Sousa" userId="02386067-c46f-46e6-bf61-8f6a774af0e5" providerId="ADAL" clId="{73C3FE35-BF7E-418C-A7F8-FA0AB4F63A6B}" dt="2026-06-02T18:19:05.993" v="441" actId="164"/>
+          <ac:spMkLst>
+            <pc:docMk/>
+            <pc:sldMk cId="4196720484" sldId="265"/>
+            <ac:spMk id="18" creationId="{AF727D3A-E35C-C430-5268-63E56FC4688E}"/>
+          </ac:spMkLst>
+        </pc:spChg>
+        <pc:spChg chg="add mod">
+          <ac:chgData name="Murillo Álvaro Borges de Sousa" userId="02386067-c46f-46e6-bf61-8f6a774af0e5" providerId="ADAL" clId="{73C3FE35-BF7E-418C-A7F8-FA0AB4F63A6B}" dt="2026-06-02T18:19:05.993" v="441" actId="164"/>
+          <ac:spMkLst>
+            <pc:docMk/>
+            <pc:sldMk cId="4196720484" sldId="265"/>
+            <ac:spMk id="19" creationId="{AAD04BC0-2C1B-2626-6C84-5127B3C8A86E}"/>
+          </ac:spMkLst>
+        </pc:spChg>
+        <pc:spChg chg="add mod">
+          <ac:chgData name="Murillo Álvaro Borges de Sousa" userId="02386067-c46f-46e6-bf61-8f6a774af0e5" providerId="ADAL" clId="{73C3FE35-BF7E-418C-A7F8-FA0AB4F63A6B}" dt="2026-06-02T18:19:05.993" v="441" actId="164"/>
+          <ac:spMkLst>
+            <pc:docMk/>
+            <pc:sldMk cId="4196720484" sldId="265"/>
+            <ac:spMk id="20" creationId="{9C6110CC-5413-0C7C-FEDB-4B267FBB0CD7}"/>
+          </ac:spMkLst>
+        </pc:spChg>
+        <pc:spChg chg="add mod">
+          <ac:chgData name="Murillo Álvaro Borges de Sousa" userId="02386067-c46f-46e6-bf61-8f6a774af0e5" providerId="ADAL" clId="{73C3FE35-BF7E-418C-A7F8-FA0AB4F63A6B}" dt="2026-06-02T18:19:11.810" v="442" actId="164"/>
+          <ac:spMkLst>
+            <pc:docMk/>
+            <pc:sldMk cId="4196720484" sldId="265"/>
+            <ac:spMk id="21" creationId="{D938E15D-0725-97A0-B87C-FBF24A2E4349}"/>
+          </ac:spMkLst>
+        </pc:spChg>
+        <pc:spChg chg="add mod">
+          <ac:chgData name="Murillo Álvaro Borges de Sousa" userId="02386067-c46f-46e6-bf61-8f6a774af0e5" providerId="ADAL" clId="{73C3FE35-BF7E-418C-A7F8-FA0AB4F63A6B}" dt="2026-06-02T18:19:11.810" v="442" actId="164"/>
+          <ac:spMkLst>
+            <pc:docMk/>
+            <pc:sldMk cId="4196720484" sldId="265"/>
+            <ac:spMk id="25" creationId="{D57C48E2-3B2E-87E9-09A0-FEAD1730A968}"/>
+          </ac:spMkLst>
+        </pc:spChg>
+        <pc:spChg chg="add mod">
+          <ac:chgData name="Murillo Álvaro Borges de Sousa" userId="02386067-c46f-46e6-bf61-8f6a774af0e5" providerId="ADAL" clId="{73C3FE35-BF7E-418C-A7F8-FA0AB4F63A6B}" dt="2026-06-02T18:19:11.810" v="442" actId="164"/>
+          <ac:spMkLst>
+            <pc:docMk/>
+            <pc:sldMk cId="4196720484" sldId="265"/>
+            <ac:spMk id="26" creationId="{006589A8-8B6E-22A4-F728-3486E191A2F4}"/>
+          </ac:spMkLst>
+        </pc:spChg>
+        <pc:spChg chg="add mod">
+          <ac:chgData name="Murillo Álvaro Borges de Sousa" userId="02386067-c46f-46e6-bf61-8f6a774af0e5" providerId="ADAL" clId="{73C3FE35-BF7E-418C-A7F8-FA0AB4F63A6B}" dt="2026-06-02T18:19:11.810" v="442" actId="164"/>
+          <ac:spMkLst>
+            <pc:docMk/>
+            <pc:sldMk cId="4196720484" sldId="265"/>
+            <ac:spMk id="27" creationId="{11754AC1-AC6E-3EA1-A814-AECAB43F68FB}"/>
+          </ac:spMkLst>
+        </pc:spChg>
+        <pc:grpChg chg="add mod">
+          <ac:chgData name="Murillo Álvaro Borges de Sousa" userId="02386067-c46f-46e6-bf61-8f6a774af0e5" providerId="ADAL" clId="{73C3FE35-BF7E-418C-A7F8-FA0AB4F63A6B}" dt="2026-06-02T18:19:05.993" v="441" actId="164"/>
+          <ac:grpSpMkLst>
+            <pc:docMk/>
+            <pc:sldMk cId="4196720484" sldId="265"/>
+            <ac:grpSpMk id="29" creationId="{A0F7F135-52C0-7A7C-B0B9-676E167521BB}"/>
+          </ac:grpSpMkLst>
+        </pc:grpChg>
+        <pc:grpChg chg="add mod">
+          <ac:chgData name="Murillo Álvaro Borges de Sousa" userId="02386067-c46f-46e6-bf61-8f6a774af0e5" providerId="ADAL" clId="{73C3FE35-BF7E-418C-A7F8-FA0AB4F63A6B}" dt="2026-06-02T18:19:11.810" v="442" actId="164"/>
+          <ac:grpSpMkLst>
+            <pc:docMk/>
+            <pc:sldMk cId="4196720484" sldId="265"/>
+            <ac:grpSpMk id="30" creationId="{3C8191E6-6AC6-E6E4-D076-AE12083ED166}"/>
+          </ac:grpSpMkLst>
+        </pc:grpChg>
+        <pc:cxnChg chg="add mod">
+          <ac:chgData name="Murillo Álvaro Borges de Sousa" userId="02386067-c46f-46e6-bf61-8f6a774af0e5" providerId="ADAL" clId="{73C3FE35-BF7E-418C-A7F8-FA0AB4F63A6B}" dt="2026-06-02T18:19:05.993" v="441" actId="164"/>
+          <ac:cxnSpMkLst>
+            <pc:docMk/>
+            <pc:sldMk cId="4196720484" sldId="265"/>
+            <ac:cxnSpMk id="5" creationId="{82A421F8-EFF9-C019-5862-65AF81CB2C68}"/>
+          </ac:cxnSpMkLst>
+        </pc:cxnChg>
+        <pc:cxnChg chg="add mod">
+          <ac:chgData name="Murillo Álvaro Borges de Sousa" userId="02386067-c46f-46e6-bf61-8f6a774af0e5" providerId="ADAL" clId="{73C3FE35-BF7E-418C-A7F8-FA0AB4F63A6B}" dt="2026-06-02T18:19:05.993" v="441" actId="164"/>
+          <ac:cxnSpMkLst>
+            <pc:docMk/>
+            <pc:sldMk cId="4196720484" sldId="265"/>
+            <ac:cxnSpMk id="7" creationId="{00A30EE2-93ED-2A00-E96E-1A9EE6165D49}"/>
+          </ac:cxnSpMkLst>
+        </pc:cxnChg>
+        <pc:cxnChg chg="add mod">
+          <ac:chgData name="Murillo Álvaro Borges de Sousa" userId="02386067-c46f-46e6-bf61-8f6a774af0e5" providerId="ADAL" clId="{73C3FE35-BF7E-418C-A7F8-FA0AB4F63A6B}" dt="2026-06-02T18:19:05.993" v="441" actId="164"/>
+          <ac:cxnSpMkLst>
+            <pc:docMk/>
+            <pc:sldMk cId="4196720484" sldId="265"/>
+            <ac:cxnSpMk id="9" creationId="{FAE0A26F-A4C9-1472-F178-B9D95F19649B}"/>
+          </ac:cxnSpMkLst>
+        </pc:cxnChg>
+        <pc:cxnChg chg="add mod">
+          <ac:chgData name="Murillo Álvaro Borges de Sousa" userId="02386067-c46f-46e6-bf61-8f6a774af0e5" providerId="ADAL" clId="{73C3FE35-BF7E-418C-A7F8-FA0AB4F63A6B}" dt="2026-06-02T18:19:11.810" v="442" actId="164"/>
+          <ac:cxnSpMkLst>
+            <pc:docMk/>
+            <pc:sldMk cId="4196720484" sldId="265"/>
+            <ac:cxnSpMk id="22" creationId="{2079778B-47D1-2666-0861-C16604698386}"/>
+          </ac:cxnSpMkLst>
+        </pc:cxnChg>
+        <pc:cxnChg chg="add mod">
+          <ac:chgData name="Murillo Álvaro Borges de Sousa" userId="02386067-c46f-46e6-bf61-8f6a774af0e5" providerId="ADAL" clId="{73C3FE35-BF7E-418C-A7F8-FA0AB4F63A6B}" dt="2026-06-02T18:19:11.810" v="442" actId="164"/>
+          <ac:cxnSpMkLst>
+            <pc:docMk/>
+            <pc:sldMk cId="4196720484" sldId="265"/>
+            <ac:cxnSpMk id="23" creationId="{347D07DE-B126-74F7-EB5F-1F800BEB3455}"/>
+          </ac:cxnSpMkLst>
+        </pc:cxnChg>
+        <pc:cxnChg chg="add mod">
+          <ac:chgData name="Murillo Álvaro Borges de Sousa" userId="02386067-c46f-46e6-bf61-8f6a774af0e5" providerId="ADAL" clId="{73C3FE35-BF7E-418C-A7F8-FA0AB4F63A6B}" dt="2026-06-02T18:19:11.810" v="442" actId="164"/>
+          <ac:cxnSpMkLst>
+            <pc:docMk/>
+            <pc:sldMk cId="4196720484" sldId="265"/>
+            <ac:cxnSpMk id="24" creationId="{13ECFF32-CA15-F024-7BDE-FEE70F25DBB3}"/>
+          </ac:cxnSpMkLst>
+        </pc:cxnChg>
       </pc:sldChg>
     </pc:docChg>
   </pc:docChgLst>
@@ -11998,6 +12158,674 @@
 </p:sld>
 </file>
 
+<file path=ppt/slides/slide10.xml><?xml version="1.0" encoding="utf-8"?>
+<p:sld xmlns:a="http://schemas.openxmlformats.org/drawingml/2006/main" xmlns:r="http://schemas.openxmlformats.org/officeDocument/2006/relationships" xmlns:p="http://schemas.openxmlformats.org/presentationml/2006/main">
+  <p:cSld>
+    <p:spTree>
+      <p:nvGrpSpPr>
+        <p:cNvPr id="1" name=""/>
+        <p:cNvGrpSpPr/>
+        <p:nvPr/>
+      </p:nvGrpSpPr>
+      <p:grpSpPr>
+        <a:xfrm>
+          <a:off x="0" y="0"/>
+          <a:ext cx="0" cy="0"/>
+          <a:chOff x="0" y="0"/>
+          <a:chExt cx="0" cy="0"/>
+        </a:xfrm>
+      </p:grpSpPr>
+      <p:grpSp>
+        <p:nvGrpSpPr>
+          <p:cNvPr id="29" name="Group 28">
+            <a:extLst>
+              <a:ext uri="{FF2B5EF4-FFF2-40B4-BE49-F238E27FC236}">
+                <a16:creationId xmlns:a16="http://schemas.microsoft.com/office/drawing/2014/main" id="{A0F7F135-52C0-7A7C-B0B9-676E167521BB}"/>
+              </a:ext>
+            </a:extLst>
+          </p:cNvPr>
+          <p:cNvGrpSpPr/>
+          <p:nvPr/>
+        </p:nvGrpSpPr>
+        <p:grpSpPr>
+          <a:xfrm>
+            <a:off x="5798508" y="2994963"/>
+            <a:ext cx="2717800" cy="1317874"/>
+            <a:chOff x="5798508" y="2994963"/>
+            <a:chExt cx="2717800" cy="1317874"/>
+          </a:xfrm>
+        </p:grpSpPr>
+        <p:sp>
+          <p:nvSpPr>
+            <p:cNvPr id="3" name="Cylinder 2">
+              <a:extLst>
+                <a:ext uri="{FF2B5EF4-FFF2-40B4-BE49-F238E27FC236}">
+                  <a16:creationId xmlns:a16="http://schemas.microsoft.com/office/drawing/2014/main" id="{4D6B3DB7-F0C9-6D0A-542E-1958730A76AF}"/>
+                </a:ext>
+              </a:extLst>
+            </p:cNvPr>
+            <p:cNvSpPr/>
+            <p:nvPr/>
+          </p:nvSpPr>
+          <p:spPr>
+            <a:xfrm rot="5400000">
+              <a:off x="6664866" y="3250266"/>
+              <a:ext cx="347347" cy="1777796"/>
+            </a:xfrm>
+            <a:prstGeom prst="can">
+              <a:avLst/>
+            </a:prstGeom>
+            <a:noFill/>
+            <a:ln>
+              <a:solidFill>
+                <a:schemeClr val="tx1"/>
+              </a:solidFill>
+            </a:ln>
+          </p:spPr>
+          <p:style>
+            <a:lnRef idx="2">
+              <a:schemeClr val="accent1">
+                <a:shade val="15000"/>
+              </a:schemeClr>
+            </a:lnRef>
+            <a:fillRef idx="1">
+              <a:schemeClr val="accent1"/>
+            </a:fillRef>
+            <a:effectRef idx="0">
+              <a:schemeClr val="accent1"/>
+            </a:effectRef>
+            <a:fontRef idx="minor">
+              <a:schemeClr val="lt1"/>
+            </a:fontRef>
+          </p:style>
+          <p:txBody>
+            <a:bodyPr rtlCol="0" anchor="ctr"/>
+            <a:lstStyle/>
+            <a:p>
+              <a:pPr algn="ctr"/>
+              <a:endParaRPr lang="pt-BR"/>
+            </a:p>
+          </p:txBody>
+        </p:sp>
+        <p:cxnSp>
+          <p:nvCxnSpPr>
+            <p:cNvPr id="5" name="Straight Arrow Connector 4">
+              <a:extLst>
+                <a:ext uri="{FF2B5EF4-FFF2-40B4-BE49-F238E27FC236}">
+                  <a16:creationId xmlns:a16="http://schemas.microsoft.com/office/drawing/2014/main" id="{82A421F8-EFF9-C019-5862-65AF81CB2C68}"/>
+                </a:ext>
+              </a:extLst>
+            </p:cNvPr>
+            <p:cNvCxnSpPr>
+              <a:cxnSpLocks/>
+            </p:cNvCxnSpPr>
+            <p:nvPr/>
+          </p:nvCxnSpPr>
+          <p:spPr>
+            <a:xfrm flipH="1" flipV="1">
+              <a:off x="5949642" y="3364296"/>
+              <a:ext cx="1" cy="774867"/>
+            </a:xfrm>
+            <a:prstGeom prst="straightConnector1">
+              <a:avLst/>
+            </a:prstGeom>
+            <a:ln>
+              <a:solidFill>
+                <a:schemeClr val="tx1"/>
+              </a:solidFill>
+              <a:tailEnd type="triangle"/>
+            </a:ln>
+          </p:spPr>
+          <p:style>
+            <a:lnRef idx="2">
+              <a:schemeClr val="accent1"/>
+            </a:lnRef>
+            <a:fillRef idx="0">
+              <a:schemeClr val="accent1"/>
+            </a:fillRef>
+            <a:effectRef idx="1">
+              <a:schemeClr val="accent1"/>
+            </a:effectRef>
+            <a:fontRef idx="minor">
+              <a:schemeClr val="tx1"/>
+            </a:fontRef>
+          </p:style>
+        </p:cxnSp>
+        <p:cxnSp>
+          <p:nvCxnSpPr>
+            <p:cNvPr id="7" name="Straight Arrow Connector 6">
+              <a:extLst>
+                <a:ext uri="{FF2B5EF4-FFF2-40B4-BE49-F238E27FC236}">
+                  <a16:creationId xmlns:a16="http://schemas.microsoft.com/office/drawing/2014/main" id="{00A30EE2-93ED-2A00-E96E-1A9EE6165D49}"/>
+                </a:ext>
+              </a:extLst>
+            </p:cNvPr>
+            <p:cNvCxnSpPr>
+              <a:cxnSpLocks/>
+            </p:cNvCxnSpPr>
+            <p:nvPr/>
+          </p:nvCxnSpPr>
+          <p:spPr>
+            <a:xfrm>
+              <a:off x="5949643" y="4139163"/>
+              <a:ext cx="2240935" cy="0"/>
+            </a:xfrm>
+            <a:prstGeom prst="straightConnector1">
+              <a:avLst/>
+            </a:prstGeom>
+            <a:ln>
+              <a:solidFill>
+                <a:schemeClr val="tx1"/>
+              </a:solidFill>
+              <a:tailEnd type="triangle"/>
+            </a:ln>
+          </p:spPr>
+          <p:style>
+            <a:lnRef idx="2">
+              <a:schemeClr val="accent1"/>
+            </a:lnRef>
+            <a:fillRef idx="0">
+              <a:schemeClr val="accent1"/>
+            </a:fillRef>
+            <a:effectRef idx="1">
+              <a:schemeClr val="accent1"/>
+            </a:effectRef>
+            <a:fontRef idx="minor">
+              <a:schemeClr val="tx1"/>
+            </a:fontRef>
+          </p:style>
+        </p:cxnSp>
+        <p:cxnSp>
+          <p:nvCxnSpPr>
+            <p:cNvPr id="9" name="Straight Arrow Connector 8">
+              <a:extLst>
+                <a:ext uri="{FF2B5EF4-FFF2-40B4-BE49-F238E27FC236}">
+                  <a16:creationId xmlns:a16="http://schemas.microsoft.com/office/drawing/2014/main" id="{FAE0A26F-A4C9-1472-F178-B9D95F19649B}"/>
+                </a:ext>
+              </a:extLst>
+            </p:cNvPr>
+            <p:cNvCxnSpPr>
+              <a:cxnSpLocks/>
+            </p:cNvCxnSpPr>
+            <p:nvPr/>
+          </p:nvCxnSpPr>
+          <p:spPr>
+            <a:xfrm flipV="1">
+              <a:off x="5949642" y="3705711"/>
+              <a:ext cx="317132" cy="433452"/>
+            </a:xfrm>
+            <a:prstGeom prst="straightConnector1">
+              <a:avLst/>
+            </a:prstGeom>
+            <a:ln>
+              <a:solidFill>
+                <a:schemeClr val="tx1"/>
+              </a:solidFill>
+              <a:tailEnd type="triangle"/>
+            </a:ln>
+          </p:spPr>
+          <p:style>
+            <a:lnRef idx="2">
+              <a:schemeClr val="accent1"/>
+            </a:lnRef>
+            <a:fillRef idx="0">
+              <a:schemeClr val="accent1"/>
+            </a:fillRef>
+            <a:effectRef idx="1">
+              <a:schemeClr val="accent1"/>
+            </a:effectRef>
+            <a:fontRef idx="minor">
+              <a:schemeClr val="tx1"/>
+            </a:fontRef>
+          </p:style>
+        </p:cxnSp>
+        <p:sp>
+          <p:nvSpPr>
+            <p:cNvPr id="18" name="TextBox 17">
+              <a:extLst>
+                <a:ext uri="{FF2B5EF4-FFF2-40B4-BE49-F238E27FC236}">
+                  <a16:creationId xmlns:a16="http://schemas.microsoft.com/office/drawing/2014/main" id="{AF727D3A-E35C-C430-5268-63E56FC4688E}"/>
+                </a:ext>
+              </a:extLst>
+            </p:cNvPr>
+            <p:cNvSpPr txBox="1"/>
+            <p:nvPr/>
+          </p:nvSpPr>
+          <p:spPr>
+            <a:xfrm>
+              <a:off x="5798508" y="2994963"/>
+              <a:ext cx="351378" cy="369332"/>
+            </a:xfrm>
+            <a:prstGeom prst="rect">
+              <a:avLst/>
+            </a:prstGeom>
+            <a:noFill/>
+          </p:spPr>
+          <p:txBody>
+            <a:bodyPr wrap="none" rtlCol="0">
+              <a:spAutoFit/>
+            </a:bodyPr>
+            <a:lstStyle/>
+            <a:p>
+              <a:r>
+                <a:rPr lang="pt-BR" dirty="0">
+                  <a:latin typeface="Times New Roman" panose="02020603050405020304" pitchFamily="18" charset="0"/>
+                  <a:cs typeface="Times New Roman" panose="02020603050405020304" pitchFamily="18" charset="0"/>
+                </a:rPr>
+                <a:t>Y</a:t>
+              </a:r>
+            </a:p>
+          </p:txBody>
+        </p:sp>
+        <p:sp>
+          <p:nvSpPr>
+            <p:cNvPr id="19" name="TextBox 18">
+              <a:extLst>
+                <a:ext uri="{FF2B5EF4-FFF2-40B4-BE49-F238E27FC236}">
+                  <a16:creationId xmlns:a16="http://schemas.microsoft.com/office/drawing/2014/main" id="{AAD04BC0-2C1B-2626-6C84-5127B3C8A86E}"/>
+                </a:ext>
+              </a:extLst>
+            </p:cNvPr>
+            <p:cNvSpPr txBox="1"/>
+            <p:nvPr/>
+          </p:nvSpPr>
+          <p:spPr>
+            <a:xfrm>
+              <a:off x="6152908" y="3347370"/>
+              <a:ext cx="351378" cy="369332"/>
+            </a:xfrm>
+            <a:prstGeom prst="rect">
+              <a:avLst/>
+            </a:prstGeom>
+            <a:noFill/>
+          </p:spPr>
+          <p:txBody>
+            <a:bodyPr wrap="none" rtlCol="0">
+              <a:spAutoFit/>
+            </a:bodyPr>
+            <a:lstStyle/>
+            <a:p>
+              <a:r>
+                <a:rPr lang="pt-BR" dirty="0">
+                  <a:latin typeface="Times New Roman" panose="02020603050405020304" pitchFamily="18" charset="0"/>
+                  <a:cs typeface="Times New Roman" panose="02020603050405020304" pitchFamily="18" charset="0"/>
+                </a:rPr>
+                <a:t>X</a:t>
+              </a:r>
+            </a:p>
+          </p:txBody>
+        </p:sp>
+        <p:sp>
+          <p:nvSpPr>
+            <p:cNvPr id="20" name="TextBox 19">
+              <a:extLst>
+                <a:ext uri="{FF2B5EF4-FFF2-40B4-BE49-F238E27FC236}">
+                  <a16:creationId xmlns:a16="http://schemas.microsoft.com/office/drawing/2014/main" id="{9C6110CC-5413-0C7C-FEDB-4B267FBB0CD7}"/>
+                </a:ext>
+              </a:extLst>
+            </p:cNvPr>
+            <p:cNvSpPr txBox="1"/>
+            <p:nvPr/>
+          </p:nvSpPr>
+          <p:spPr>
+            <a:xfrm>
+              <a:off x="8190578" y="3922437"/>
+              <a:ext cx="325730" cy="369332"/>
+            </a:xfrm>
+            <a:prstGeom prst="rect">
+              <a:avLst/>
+            </a:prstGeom>
+            <a:noFill/>
+          </p:spPr>
+          <p:txBody>
+            <a:bodyPr wrap="none" rtlCol="0">
+              <a:spAutoFit/>
+            </a:bodyPr>
+            <a:lstStyle/>
+            <a:p>
+              <a:r>
+                <a:rPr lang="pt-BR" dirty="0">
+                  <a:latin typeface="Times New Roman" panose="02020603050405020304" pitchFamily="18" charset="0"/>
+                  <a:cs typeface="Times New Roman" panose="02020603050405020304" pitchFamily="18" charset="0"/>
+                </a:rPr>
+                <a:t>Z</a:t>
+              </a:r>
+            </a:p>
+          </p:txBody>
+        </p:sp>
+      </p:grpSp>
+      <p:grpSp>
+        <p:nvGrpSpPr>
+          <p:cNvPr id="30" name="Group 29">
+            <a:extLst>
+              <a:ext uri="{FF2B5EF4-FFF2-40B4-BE49-F238E27FC236}">
+                <a16:creationId xmlns:a16="http://schemas.microsoft.com/office/drawing/2014/main" id="{3C8191E6-6AC6-E6E4-D076-AE12083ED166}"/>
+              </a:ext>
+            </a:extLst>
+          </p:cNvPr>
+          <p:cNvGrpSpPr/>
+          <p:nvPr/>
+        </p:nvGrpSpPr>
+        <p:grpSpPr>
+          <a:xfrm>
+            <a:off x="1821005" y="2999412"/>
+            <a:ext cx="3127978" cy="1914008"/>
+            <a:chOff x="1821005" y="2999412"/>
+            <a:chExt cx="3127978" cy="1914008"/>
+          </a:xfrm>
+        </p:grpSpPr>
+        <p:sp>
+          <p:nvSpPr>
+            <p:cNvPr id="21" name="Cylinder 20">
+              <a:extLst>
+                <a:ext uri="{FF2B5EF4-FFF2-40B4-BE49-F238E27FC236}">
+                  <a16:creationId xmlns:a16="http://schemas.microsoft.com/office/drawing/2014/main" id="{D938E15D-0725-97A0-B87C-FBF24A2E4349}"/>
+                </a:ext>
+              </a:extLst>
+            </p:cNvPr>
+            <p:cNvSpPr/>
+            <p:nvPr/>
+          </p:nvSpPr>
+          <p:spPr>
+            <a:xfrm rot="5400000">
+              <a:off x="3063295" y="3243721"/>
+              <a:ext cx="347347" cy="1777796"/>
+            </a:xfrm>
+            <a:prstGeom prst="can">
+              <a:avLst/>
+            </a:prstGeom>
+            <a:noFill/>
+            <a:ln>
+              <a:solidFill>
+                <a:schemeClr val="tx1"/>
+              </a:solidFill>
+            </a:ln>
+          </p:spPr>
+          <p:style>
+            <a:lnRef idx="2">
+              <a:schemeClr val="accent1">
+                <a:shade val="15000"/>
+              </a:schemeClr>
+            </a:lnRef>
+            <a:fillRef idx="1">
+              <a:schemeClr val="accent1"/>
+            </a:fillRef>
+            <a:effectRef idx="0">
+              <a:schemeClr val="accent1"/>
+            </a:effectRef>
+            <a:fontRef idx="minor">
+              <a:schemeClr val="lt1"/>
+            </a:fontRef>
+          </p:style>
+          <p:txBody>
+            <a:bodyPr rtlCol="0" anchor="ctr"/>
+            <a:lstStyle/>
+            <a:p>
+              <a:pPr algn="ctr"/>
+              <a:endParaRPr lang="pt-BR"/>
+            </a:p>
+          </p:txBody>
+        </p:sp>
+        <p:cxnSp>
+          <p:nvCxnSpPr>
+            <p:cNvPr id="22" name="Straight Arrow Connector 21">
+              <a:extLst>
+                <a:ext uri="{FF2B5EF4-FFF2-40B4-BE49-F238E27FC236}">
+                  <a16:creationId xmlns:a16="http://schemas.microsoft.com/office/drawing/2014/main" id="{2079778B-47D1-2666-0861-C16604698386}"/>
+                </a:ext>
+              </a:extLst>
+            </p:cNvPr>
+            <p:cNvCxnSpPr>
+              <a:cxnSpLocks/>
+            </p:cNvCxnSpPr>
+            <p:nvPr/>
+          </p:nvCxnSpPr>
+          <p:spPr>
+            <a:xfrm flipH="1" flipV="1">
+              <a:off x="2348071" y="3357751"/>
+              <a:ext cx="1" cy="774867"/>
+            </a:xfrm>
+            <a:prstGeom prst="straightConnector1">
+              <a:avLst/>
+            </a:prstGeom>
+            <a:ln>
+              <a:solidFill>
+                <a:schemeClr val="tx1"/>
+              </a:solidFill>
+              <a:tailEnd type="triangle"/>
+            </a:ln>
+          </p:spPr>
+          <p:style>
+            <a:lnRef idx="2">
+              <a:schemeClr val="accent1"/>
+            </a:lnRef>
+            <a:fillRef idx="0">
+              <a:schemeClr val="accent1"/>
+            </a:fillRef>
+            <a:effectRef idx="1">
+              <a:schemeClr val="accent1"/>
+            </a:effectRef>
+            <a:fontRef idx="minor">
+              <a:schemeClr val="tx1"/>
+            </a:fontRef>
+          </p:style>
+        </p:cxnSp>
+        <p:cxnSp>
+          <p:nvCxnSpPr>
+            <p:cNvPr id="23" name="Straight Arrow Connector 22">
+              <a:extLst>
+                <a:ext uri="{FF2B5EF4-FFF2-40B4-BE49-F238E27FC236}">
+                  <a16:creationId xmlns:a16="http://schemas.microsoft.com/office/drawing/2014/main" id="{347D07DE-B126-74F7-EB5F-1F800BEB3455}"/>
+                </a:ext>
+              </a:extLst>
+            </p:cNvPr>
+            <p:cNvCxnSpPr>
+              <a:cxnSpLocks/>
+            </p:cNvCxnSpPr>
+            <p:nvPr/>
+          </p:nvCxnSpPr>
+          <p:spPr>
+            <a:xfrm>
+              <a:off x="2348072" y="4132618"/>
+              <a:ext cx="2240935" cy="0"/>
+            </a:xfrm>
+            <a:prstGeom prst="straightConnector1">
+              <a:avLst/>
+            </a:prstGeom>
+            <a:ln>
+              <a:solidFill>
+                <a:schemeClr val="tx1"/>
+              </a:solidFill>
+              <a:tailEnd type="triangle"/>
+            </a:ln>
+          </p:spPr>
+          <p:style>
+            <a:lnRef idx="2">
+              <a:schemeClr val="accent1"/>
+            </a:lnRef>
+            <a:fillRef idx="0">
+              <a:schemeClr val="accent1"/>
+            </a:fillRef>
+            <a:effectRef idx="1">
+              <a:schemeClr val="accent1"/>
+            </a:effectRef>
+            <a:fontRef idx="minor">
+              <a:schemeClr val="tx1"/>
+            </a:fontRef>
+          </p:style>
+        </p:cxnSp>
+        <p:cxnSp>
+          <p:nvCxnSpPr>
+            <p:cNvPr id="24" name="Straight Arrow Connector 23">
+              <a:extLst>
+                <a:ext uri="{FF2B5EF4-FFF2-40B4-BE49-F238E27FC236}">
+                  <a16:creationId xmlns:a16="http://schemas.microsoft.com/office/drawing/2014/main" id="{13ECFF32-CA15-F024-7BDE-FEE70F25DBB3}"/>
+                </a:ext>
+              </a:extLst>
+            </p:cNvPr>
+            <p:cNvCxnSpPr>
+              <a:cxnSpLocks/>
+            </p:cNvCxnSpPr>
+            <p:nvPr/>
+          </p:nvCxnSpPr>
+          <p:spPr>
+            <a:xfrm flipH="1">
+              <a:off x="2030940" y="4132618"/>
+              <a:ext cx="317131" cy="422463"/>
+            </a:xfrm>
+            <a:prstGeom prst="straightConnector1">
+              <a:avLst/>
+            </a:prstGeom>
+            <a:ln>
+              <a:solidFill>
+                <a:schemeClr val="tx1"/>
+              </a:solidFill>
+              <a:tailEnd type="triangle"/>
+            </a:ln>
+          </p:spPr>
+          <p:style>
+            <a:lnRef idx="2">
+              <a:schemeClr val="accent1"/>
+            </a:lnRef>
+            <a:fillRef idx="0">
+              <a:schemeClr val="accent1"/>
+            </a:fillRef>
+            <a:effectRef idx="1">
+              <a:schemeClr val="accent1"/>
+            </a:effectRef>
+            <a:fontRef idx="minor">
+              <a:schemeClr val="tx1"/>
+            </a:fontRef>
+          </p:style>
+        </p:cxnSp>
+        <p:sp>
+          <p:nvSpPr>
+            <p:cNvPr id="25" name="TextBox 24">
+              <a:extLst>
+                <a:ext uri="{FF2B5EF4-FFF2-40B4-BE49-F238E27FC236}">
+                  <a16:creationId xmlns:a16="http://schemas.microsoft.com/office/drawing/2014/main" id="{D57C48E2-3B2E-87E9-09A0-FEAD1730A968}"/>
+                </a:ext>
+              </a:extLst>
+            </p:cNvPr>
+            <p:cNvSpPr txBox="1"/>
+            <p:nvPr/>
+          </p:nvSpPr>
+          <p:spPr>
+            <a:xfrm>
+              <a:off x="4597605" y="3915891"/>
+              <a:ext cx="351378" cy="369332"/>
+            </a:xfrm>
+            <a:prstGeom prst="rect">
+              <a:avLst/>
+            </a:prstGeom>
+            <a:noFill/>
+          </p:spPr>
+          <p:txBody>
+            <a:bodyPr wrap="none" rtlCol="0">
+              <a:spAutoFit/>
+            </a:bodyPr>
+            <a:lstStyle/>
+            <a:p>
+              <a:r>
+                <a:rPr lang="pt-BR" dirty="0">
+                  <a:latin typeface="Times New Roman" panose="02020603050405020304" pitchFamily="18" charset="0"/>
+                  <a:cs typeface="Times New Roman" panose="02020603050405020304" pitchFamily="18" charset="0"/>
+                </a:rPr>
+                <a:t>Y</a:t>
+              </a:r>
+            </a:p>
+          </p:txBody>
+        </p:sp>
+        <p:sp>
+          <p:nvSpPr>
+            <p:cNvPr id="26" name="TextBox 25">
+              <a:extLst>
+                <a:ext uri="{FF2B5EF4-FFF2-40B4-BE49-F238E27FC236}">
+                  <a16:creationId xmlns:a16="http://schemas.microsoft.com/office/drawing/2014/main" id="{006589A8-8B6E-22A4-F728-3486E191A2F4}"/>
+                </a:ext>
+              </a:extLst>
+            </p:cNvPr>
+            <p:cNvSpPr txBox="1"/>
+            <p:nvPr/>
+          </p:nvSpPr>
+          <p:spPr>
+            <a:xfrm>
+              <a:off x="1821005" y="4544088"/>
+              <a:ext cx="351378" cy="369332"/>
+            </a:xfrm>
+            <a:prstGeom prst="rect">
+              <a:avLst/>
+            </a:prstGeom>
+            <a:noFill/>
+          </p:spPr>
+          <p:txBody>
+            <a:bodyPr wrap="none" rtlCol="0">
+              <a:spAutoFit/>
+            </a:bodyPr>
+            <a:lstStyle/>
+            <a:p>
+              <a:r>
+                <a:rPr lang="pt-BR" dirty="0">
+                  <a:latin typeface="Times New Roman" panose="02020603050405020304" pitchFamily="18" charset="0"/>
+                  <a:cs typeface="Times New Roman" panose="02020603050405020304" pitchFamily="18" charset="0"/>
+                </a:rPr>
+                <a:t>X</a:t>
+              </a:r>
+            </a:p>
+          </p:txBody>
+        </p:sp>
+        <p:sp>
+          <p:nvSpPr>
+            <p:cNvPr id="27" name="TextBox 26">
+              <a:extLst>
+                <a:ext uri="{FF2B5EF4-FFF2-40B4-BE49-F238E27FC236}">
+                  <a16:creationId xmlns:a16="http://schemas.microsoft.com/office/drawing/2014/main" id="{11754AC1-AC6E-3EA1-A814-AECAB43F68FB}"/>
+                </a:ext>
+              </a:extLst>
+            </p:cNvPr>
+            <p:cNvSpPr txBox="1"/>
+            <p:nvPr/>
+          </p:nvSpPr>
+          <p:spPr>
+            <a:xfrm>
+              <a:off x="2189505" y="2999412"/>
+              <a:ext cx="325730" cy="369332"/>
+            </a:xfrm>
+            <a:prstGeom prst="rect">
+              <a:avLst/>
+            </a:prstGeom>
+            <a:noFill/>
+          </p:spPr>
+          <p:txBody>
+            <a:bodyPr wrap="none" rtlCol="0">
+              <a:spAutoFit/>
+            </a:bodyPr>
+            <a:lstStyle/>
+            <a:p>
+              <a:r>
+                <a:rPr lang="pt-BR" dirty="0">
+                  <a:latin typeface="Times New Roman" panose="02020603050405020304" pitchFamily="18" charset="0"/>
+                  <a:cs typeface="Times New Roman" panose="02020603050405020304" pitchFamily="18" charset="0"/>
+                </a:rPr>
+                <a:t>Z</a:t>
+              </a:r>
+            </a:p>
+          </p:txBody>
+        </p:sp>
+      </p:grpSp>
+    </p:spTree>
+    <p:extLst>
+      <p:ext uri="{BB962C8B-B14F-4D97-AF65-F5344CB8AC3E}">
+        <p14:creationId xmlns:p14="http://schemas.microsoft.com/office/powerpoint/2010/main" val="4196720484"/>
+      </p:ext>
+    </p:extLst>
+  </p:cSld>
+  <p:clrMapOvr>
+    <a:masterClrMapping/>
+  </p:clrMapOvr>
+</p:sld>
+</file>
+
 <file path=ppt/slides/slide2.xml><?xml version="1.0" encoding="utf-8"?>
 <p:sld xmlns:a="http://schemas.openxmlformats.org/drawingml/2006/main" xmlns:r="http://schemas.openxmlformats.org/officeDocument/2006/relationships" xmlns:p="http://schemas.openxmlformats.org/presentationml/2006/main">
   <p:cSld>
@@ -17440,10 +18268,10 @@
       </p:grpSpPr>
       <p:grpSp>
         <p:nvGrpSpPr>
-          <p:cNvPr id="7" name="Group 6">
+          <p:cNvPr id="10" name="Group 9">
             <a:extLst>
               <a:ext uri="{FF2B5EF4-FFF2-40B4-BE49-F238E27FC236}">
-                <a16:creationId xmlns:a16="http://schemas.microsoft.com/office/drawing/2014/main" id="{1F7C3375-1F11-3A99-DAFF-60594AFA7427}"/>
+                <a16:creationId xmlns:a16="http://schemas.microsoft.com/office/drawing/2014/main" id="{FE3EBD89-0E68-3B35-525E-3ABD8515678D}"/>
               </a:ext>
             </a:extLst>
           </p:cNvPr>
@@ -17452,106 +18280,28 @@
         </p:nvGrpSpPr>
         <p:grpSpPr>
           <a:xfrm>
-            <a:off x="1818678" y="1028540"/>
-            <a:ext cx="8554644" cy="5020376"/>
-            <a:chOff x="1818678" y="1028540"/>
-            <a:chExt cx="8554644" cy="5020376"/>
+            <a:off x="1793099" y="1028539"/>
+            <a:ext cx="8704687" cy="5170380"/>
+            <a:chOff x="1793099" y="1028539"/>
+            <a:chExt cx="8704687" cy="5170380"/>
           </a:xfrm>
         </p:grpSpPr>
-        <p:pic>
-          <p:nvPicPr>
-            <p:cNvPr id="3" name="Picture 2">
+        <p:sp>
+          <p:nvSpPr>
+            <p:cNvPr id="9" name="Rectangle 8">
               <a:extLst>
                 <a:ext uri="{FF2B5EF4-FFF2-40B4-BE49-F238E27FC236}">
-                  <a16:creationId xmlns:a16="http://schemas.microsoft.com/office/drawing/2014/main" id="{C395F624-29E7-EB8D-AA14-ACD11D1DD967}"/>
+                  <a16:creationId xmlns:a16="http://schemas.microsoft.com/office/drawing/2014/main" id="{E6CBC1F0-97FD-DA72-ED5A-E7D463CC8A68}"/>
                 </a:ext>
               </a:extLst>
             </p:cNvPr>
-            <p:cNvPicPr>
-              <a:picLocks noChangeAspect="1"/>
-            </p:cNvPicPr>
-            <p:nvPr/>
-          </p:nvPicPr>
-          <p:blipFill>
-            <a:blip r:embed="rId2">
-              <a:extLst>
-                <a:ext uri="{28A0092B-C50C-407E-A947-70E740481C1C}">
-                  <a14:useLocalDpi xmlns:a14="http://schemas.microsoft.com/office/drawing/2010/main" val="0"/>
-                </a:ext>
-              </a:extLst>
-            </a:blip>
-            <a:stretch>
-              <a:fillRect/>
-            </a:stretch>
-          </p:blipFill>
-          <p:spPr>
-            <a:xfrm>
-              <a:off x="1818678" y="1028540"/>
-              <a:ext cx="8554644" cy="5020376"/>
-            </a:xfrm>
-            <a:prstGeom prst="rect">
-              <a:avLst/>
-            </a:prstGeom>
-          </p:spPr>
-        </p:pic>
-        <p:sp>
-          <p:nvSpPr>
-            <p:cNvPr id="4" name="TextBox 3">
-              <a:extLst>
-                <a:ext uri="{FF2B5EF4-FFF2-40B4-BE49-F238E27FC236}">
-                  <a16:creationId xmlns:a16="http://schemas.microsoft.com/office/drawing/2014/main" id="{52DD1A79-310E-A78E-9BDB-78E99881CC90}"/>
-                </a:ext>
-              </a:extLst>
-            </p:cNvPr>
-            <p:cNvSpPr txBox="1"/>
+            <p:cNvSpPr/>
             <p:nvPr/>
           </p:nvSpPr>
           <p:spPr>
             <a:xfrm>
-              <a:off x="8607552" y="3755136"/>
-              <a:ext cx="1162241" cy="400110"/>
-            </a:xfrm>
-            <a:prstGeom prst="rect">
-              <a:avLst/>
-            </a:prstGeom>
-            <a:noFill/>
-          </p:spPr>
-          <p:txBody>
-            <a:bodyPr wrap="none" rtlCol="0">
-              <a:spAutoFit/>
-            </a:bodyPr>
-            <a:lstStyle/>
-            <a:p>
-              <a:r>
-                <a:rPr lang="pt-BR" sz="2000" dirty="0">
-                  <a:latin typeface="Times New Roman" panose="02020603050405020304" pitchFamily="18" charset="0"/>
-                  <a:cs typeface="Times New Roman" panose="02020603050405020304" pitchFamily="18" charset="0"/>
-                </a:rPr>
-                <a:t>Torcional</a:t>
-              </a:r>
-              <a:endParaRPr lang="pt-BR" dirty="0">
-                <a:latin typeface="Times New Roman" panose="02020603050405020304" pitchFamily="18" charset="0"/>
-                <a:cs typeface="Times New Roman" panose="02020603050405020304" pitchFamily="18" charset="0"/>
-              </a:endParaRPr>
-            </a:p>
-          </p:txBody>
-        </p:sp>
-        <p:sp>
-          <p:nvSpPr>
-            <p:cNvPr id="5" name="TextBox 4">
-              <a:extLst>
-                <a:ext uri="{FF2B5EF4-FFF2-40B4-BE49-F238E27FC236}">
-                  <a16:creationId xmlns:a16="http://schemas.microsoft.com/office/drawing/2014/main" id="{D3DE5C22-CA75-31F6-D542-30E5945083D9}"/>
-                </a:ext>
-              </a:extLst>
-            </p:cNvPr>
-            <p:cNvSpPr txBox="1"/>
-            <p:nvPr/>
-          </p:nvSpPr>
-          <p:spPr>
-            <a:xfrm>
-              <a:off x="4845218" y="5589067"/>
-              <a:ext cx="3212592" cy="400110"/>
+              <a:off x="1793099" y="1028539"/>
+              <a:ext cx="8704687" cy="5170380"/>
             </a:xfrm>
             <a:prstGeom prst="rect">
               <a:avLst/>
@@ -17559,63 +18309,216 @@
             <a:solidFill>
               <a:schemeClr val="bg1"/>
             </a:solidFill>
+            <a:ln>
+              <a:solidFill>
+                <a:schemeClr val="bg1"/>
+              </a:solidFill>
+            </a:ln>
           </p:spPr>
+          <p:style>
+            <a:lnRef idx="2">
+              <a:schemeClr val="accent1">
+                <a:shade val="15000"/>
+              </a:schemeClr>
+            </a:lnRef>
+            <a:fillRef idx="1">
+              <a:schemeClr val="accent1"/>
+            </a:fillRef>
+            <a:effectRef idx="0">
+              <a:schemeClr val="accent1"/>
+            </a:effectRef>
+            <a:fontRef idx="minor">
+              <a:schemeClr val="lt1"/>
+            </a:fontRef>
+          </p:style>
           <p:txBody>
-            <a:bodyPr wrap="square" rtlCol="0">
-              <a:spAutoFit/>
-            </a:bodyPr>
+            <a:bodyPr rtlCol="0" anchor="ctr"/>
             <a:lstStyle/>
             <a:p>
-              <a:r>
-                <a:rPr lang="pt-BR" sz="2000" dirty="0">
-                  <a:latin typeface="Times New Roman" panose="02020603050405020304" pitchFamily="18" charset="0"/>
-                  <a:cs typeface="Times New Roman" panose="02020603050405020304" pitchFamily="18" charset="0"/>
-                </a:rPr>
-                <a:t>Velocidade de Rotação [rpm]</a:t>
-              </a:r>
+              <a:pPr algn="ctr"/>
+              <a:endParaRPr lang="pt-BR"/>
             </a:p>
           </p:txBody>
         </p:sp>
-        <p:sp>
-          <p:nvSpPr>
-            <p:cNvPr id="6" name="TextBox 5">
+        <p:grpSp>
+          <p:nvGrpSpPr>
+            <p:cNvPr id="7" name="Group 6">
               <a:extLst>
                 <a:ext uri="{FF2B5EF4-FFF2-40B4-BE49-F238E27FC236}">
-                  <a16:creationId xmlns:a16="http://schemas.microsoft.com/office/drawing/2014/main" id="{968B5D67-F3CD-C562-F708-B396E50213D8}"/>
+                  <a16:creationId xmlns:a16="http://schemas.microsoft.com/office/drawing/2014/main" id="{1F7C3375-1F11-3A99-DAFF-60594AFA7427}"/>
                 </a:ext>
               </a:extLst>
             </p:cNvPr>
-            <p:cNvSpPr txBox="1"/>
+            <p:cNvGrpSpPr/>
             <p:nvPr/>
-          </p:nvSpPr>
-          <p:spPr>
-            <a:xfrm rot="16200000">
-              <a:off x="644004" y="2919354"/>
-              <a:ext cx="3212592" cy="400110"/>
+          </p:nvGrpSpPr>
+          <p:grpSpPr>
+            <a:xfrm>
+              <a:off x="1868120" y="1103541"/>
+              <a:ext cx="8554644" cy="5020376"/>
+              <a:chOff x="1818678" y="1028540"/>
+              <a:chExt cx="8554644" cy="5020376"/>
             </a:xfrm>
-            <a:prstGeom prst="rect">
-              <a:avLst/>
-            </a:prstGeom>
-            <a:solidFill>
-              <a:schemeClr val="bg1"/>
-            </a:solidFill>
-          </p:spPr>
-          <p:txBody>
-            <a:bodyPr wrap="square" rtlCol="0">
-              <a:spAutoFit/>
-            </a:bodyPr>
-            <a:lstStyle/>
-            <a:p>
-              <a:r>
-                <a:rPr lang="pt-BR" sz="2000" dirty="0">
+          </p:grpSpPr>
+          <p:pic>
+            <p:nvPicPr>
+              <p:cNvPr id="3" name="Picture 2">
+                <a:extLst>
+                  <a:ext uri="{FF2B5EF4-FFF2-40B4-BE49-F238E27FC236}">
+                    <a16:creationId xmlns:a16="http://schemas.microsoft.com/office/drawing/2014/main" id="{C395F624-29E7-EB8D-AA14-ACD11D1DD967}"/>
+                  </a:ext>
+                </a:extLst>
+              </p:cNvPr>
+              <p:cNvPicPr>
+                <a:picLocks noChangeAspect="1"/>
+              </p:cNvPicPr>
+              <p:nvPr/>
+            </p:nvPicPr>
+            <p:blipFill>
+              <a:blip r:embed="rId2">
+                <a:extLst>
+                  <a:ext uri="{28A0092B-C50C-407E-A947-70E740481C1C}">
+                    <a14:useLocalDpi xmlns:a14="http://schemas.microsoft.com/office/drawing/2010/main" val="0"/>
+                  </a:ext>
+                </a:extLst>
+              </a:blip>
+              <a:stretch>
+                <a:fillRect/>
+              </a:stretch>
+            </p:blipFill>
+            <p:spPr>
+              <a:xfrm>
+                <a:off x="1818678" y="1028540"/>
+                <a:ext cx="8554644" cy="5020376"/>
+              </a:xfrm>
+              <a:prstGeom prst="rect">
+                <a:avLst/>
+              </a:prstGeom>
+            </p:spPr>
+          </p:pic>
+          <p:sp>
+            <p:nvSpPr>
+              <p:cNvPr id="4" name="TextBox 3">
+                <a:extLst>
+                  <a:ext uri="{FF2B5EF4-FFF2-40B4-BE49-F238E27FC236}">
+                    <a16:creationId xmlns:a16="http://schemas.microsoft.com/office/drawing/2014/main" id="{52DD1A79-310E-A78E-9BDB-78E99881CC90}"/>
+                  </a:ext>
+                </a:extLst>
+              </p:cNvPr>
+              <p:cNvSpPr txBox="1"/>
+              <p:nvPr/>
+            </p:nvSpPr>
+            <p:spPr>
+              <a:xfrm>
+                <a:off x="8607552" y="3755136"/>
+                <a:ext cx="1162241" cy="400110"/>
+              </a:xfrm>
+              <a:prstGeom prst="rect">
+                <a:avLst/>
+              </a:prstGeom>
+              <a:noFill/>
+            </p:spPr>
+            <p:txBody>
+              <a:bodyPr wrap="none" rtlCol="0">
+                <a:spAutoFit/>
+              </a:bodyPr>
+              <a:lstStyle/>
+              <a:p>
+                <a:r>
+                  <a:rPr lang="pt-BR" sz="2000" dirty="0">
+                    <a:latin typeface="Times New Roman" panose="02020603050405020304" pitchFamily="18" charset="0"/>
+                    <a:cs typeface="Times New Roman" panose="02020603050405020304" pitchFamily="18" charset="0"/>
+                  </a:rPr>
+                  <a:t>Torcional</a:t>
+                </a:r>
+                <a:endParaRPr lang="pt-BR" dirty="0">
                   <a:latin typeface="Times New Roman" panose="02020603050405020304" pitchFamily="18" charset="0"/>
                   <a:cs typeface="Times New Roman" panose="02020603050405020304" pitchFamily="18" charset="0"/>
-                </a:rPr>
-                <a:t>Frequência Natural [Hz]</a:t>
-              </a:r>
-            </a:p>
-          </p:txBody>
-        </p:sp>
+                </a:endParaRPr>
+              </a:p>
+            </p:txBody>
+          </p:sp>
+          <p:sp>
+            <p:nvSpPr>
+              <p:cNvPr id="5" name="TextBox 4">
+                <a:extLst>
+                  <a:ext uri="{FF2B5EF4-FFF2-40B4-BE49-F238E27FC236}">
+                    <a16:creationId xmlns:a16="http://schemas.microsoft.com/office/drawing/2014/main" id="{D3DE5C22-CA75-31F6-D542-30E5945083D9}"/>
+                  </a:ext>
+                </a:extLst>
+              </p:cNvPr>
+              <p:cNvSpPr txBox="1"/>
+              <p:nvPr/>
+            </p:nvSpPr>
+            <p:spPr>
+              <a:xfrm>
+                <a:off x="4845218" y="5589067"/>
+                <a:ext cx="3212592" cy="400110"/>
+              </a:xfrm>
+              <a:prstGeom prst="rect">
+                <a:avLst/>
+              </a:prstGeom>
+              <a:solidFill>
+                <a:schemeClr val="bg1"/>
+              </a:solidFill>
+            </p:spPr>
+            <p:txBody>
+              <a:bodyPr wrap="square" rtlCol="0">
+                <a:spAutoFit/>
+              </a:bodyPr>
+              <a:lstStyle/>
+              <a:p>
+                <a:r>
+                  <a:rPr lang="pt-BR" sz="2000" dirty="0">
+                    <a:latin typeface="Times New Roman" panose="02020603050405020304" pitchFamily="18" charset="0"/>
+                    <a:cs typeface="Times New Roman" panose="02020603050405020304" pitchFamily="18" charset="0"/>
+                  </a:rPr>
+                  <a:t>Velocidade de Rotação [rpm]</a:t>
+                </a:r>
+              </a:p>
+            </p:txBody>
+          </p:sp>
+          <p:sp>
+            <p:nvSpPr>
+              <p:cNvPr id="6" name="TextBox 5">
+                <a:extLst>
+                  <a:ext uri="{FF2B5EF4-FFF2-40B4-BE49-F238E27FC236}">
+                    <a16:creationId xmlns:a16="http://schemas.microsoft.com/office/drawing/2014/main" id="{968B5D67-F3CD-C562-F708-B396E50213D8}"/>
+                  </a:ext>
+                </a:extLst>
+              </p:cNvPr>
+              <p:cNvSpPr txBox="1"/>
+              <p:nvPr/>
+            </p:nvSpPr>
+            <p:spPr>
+              <a:xfrm rot="16200000">
+                <a:off x="644004" y="2919354"/>
+                <a:ext cx="3212592" cy="400110"/>
+              </a:xfrm>
+              <a:prstGeom prst="rect">
+                <a:avLst/>
+              </a:prstGeom>
+              <a:solidFill>
+                <a:schemeClr val="bg1"/>
+              </a:solidFill>
+            </p:spPr>
+            <p:txBody>
+              <a:bodyPr wrap="square" rtlCol="0">
+                <a:spAutoFit/>
+              </a:bodyPr>
+              <a:lstStyle/>
+              <a:p>
+                <a:r>
+                  <a:rPr lang="pt-BR" sz="2000" dirty="0">
+                    <a:latin typeface="Times New Roman" panose="02020603050405020304" pitchFamily="18" charset="0"/>
+                    <a:cs typeface="Times New Roman" panose="02020603050405020304" pitchFamily="18" charset="0"/>
+                  </a:rPr>
+                  <a:t>Frequência Natural [Hz]</a:t>
+                </a:r>
+              </a:p>
+            </p:txBody>
+          </p:sp>
+        </p:grpSp>
       </p:grpSp>
     </p:spTree>
     <p:extLst>

</xml_diff>

<commit_message>
adding figures and results
</commit_message>
<xml_diff>
--- a/DISSERTACAO/figuras/figures.pptx
+++ b/DISSERTACAO/figuras/figures.pptx
@@ -1317,7 +1317,7 @@
           <a:p>
             <a:fld id="{FFCE6A37-3420-40C1-9DE2-D7E9118C4CF6}" type="datetimeFigureOut">
               <a:rPr lang="pt-BR" smtClean="0"/>
-              <a:t>08/06/2026</a:t>
+              <a:t>09/06/2026</a:t>
             </a:fld>
             <a:endParaRPr lang="pt-BR"/>
           </a:p>
@@ -1818,7 +1818,7 @@
           <a:p>
             <a:fld id="{7C8BC570-9881-4DD1-A666-BFFC3ABED690}" type="datetimeFigureOut">
               <a:rPr lang="pt-BR" smtClean="0"/>
-              <a:t>08/06/2026</a:t>
+              <a:t>09/06/2026</a:t>
             </a:fld>
             <a:endParaRPr lang="pt-BR"/>
           </a:p>
@@ -2018,7 +2018,7 @@
           <a:p>
             <a:fld id="{7C8BC570-9881-4DD1-A666-BFFC3ABED690}" type="datetimeFigureOut">
               <a:rPr lang="pt-BR" smtClean="0"/>
-              <a:t>08/06/2026</a:t>
+              <a:t>09/06/2026</a:t>
             </a:fld>
             <a:endParaRPr lang="pt-BR"/>
           </a:p>
@@ -2228,7 +2228,7 @@
           <a:p>
             <a:fld id="{7C8BC570-9881-4DD1-A666-BFFC3ABED690}" type="datetimeFigureOut">
               <a:rPr lang="pt-BR" smtClean="0"/>
-              <a:t>08/06/2026</a:t>
+              <a:t>09/06/2026</a:t>
             </a:fld>
             <a:endParaRPr lang="pt-BR"/>
           </a:p>
@@ -2428,7 +2428,7 @@
           <a:p>
             <a:fld id="{7C8BC570-9881-4DD1-A666-BFFC3ABED690}" type="datetimeFigureOut">
               <a:rPr lang="pt-BR" smtClean="0"/>
-              <a:t>08/06/2026</a:t>
+              <a:t>09/06/2026</a:t>
             </a:fld>
             <a:endParaRPr lang="pt-BR"/>
           </a:p>
@@ -2704,7 +2704,7 @@
           <a:p>
             <a:fld id="{7C8BC570-9881-4DD1-A666-BFFC3ABED690}" type="datetimeFigureOut">
               <a:rPr lang="pt-BR" smtClean="0"/>
-              <a:t>08/06/2026</a:t>
+              <a:t>09/06/2026</a:t>
             </a:fld>
             <a:endParaRPr lang="pt-BR"/>
           </a:p>
@@ -2972,7 +2972,7 @@
           <a:p>
             <a:fld id="{7C8BC570-9881-4DD1-A666-BFFC3ABED690}" type="datetimeFigureOut">
               <a:rPr lang="pt-BR" smtClean="0"/>
-              <a:t>08/06/2026</a:t>
+              <a:t>09/06/2026</a:t>
             </a:fld>
             <a:endParaRPr lang="pt-BR"/>
           </a:p>
@@ -3387,7 +3387,7 @@
           <a:p>
             <a:fld id="{7C8BC570-9881-4DD1-A666-BFFC3ABED690}" type="datetimeFigureOut">
               <a:rPr lang="pt-BR" smtClean="0"/>
-              <a:t>08/06/2026</a:t>
+              <a:t>09/06/2026</a:t>
             </a:fld>
             <a:endParaRPr lang="pt-BR"/>
           </a:p>
@@ -3529,7 +3529,7 @@
           <a:p>
             <a:fld id="{7C8BC570-9881-4DD1-A666-BFFC3ABED690}" type="datetimeFigureOut">
               <a:rPr lang="pt-BR" smtClean="0"/>
-              <a:t>08/06/2026</a:t>
+              <a:t>09/06/2026</a:t>
             </a:fld>
             <a:endParaRPr lang="pt-BR"/>
           </a:p>
@@ -3642,7 +3642,7 @@
           <a:p>
             <a:fld id="{7C8BC570-9881-4DD1-A666-BFFC3ABED690}" type="datetimeFigureOut">
               <a:rPr lang="pt-BR" smtClean="0"/>
-              <a:t>08/06/2026</a:t>
+              <a:t>09/06/2026</a:t>
             </a:fld>
             <a:endParaRPr lang="pt-BR"/>
           </a:p>
@@ -3955,7 +3955,7 @@
           <a:p>
             <a:fld id="{7C8BC570-9881-4DD1-A666-BFFC3ABED690}" type="datetimeFigureOut">
               <a:rPr lang="pt-BR" smtClean="0"/>
-              <a:t>08/06/2026</a:t>
+              <a:t>09/06/2026</a:t>
             </a:fld>
             <a:endParaRPr lang="pt-BR"/>
           </a:p>
@@ -4244,7 +4244,7 @@
           <a:p>
             <a:fld id="{7C8BC570-9881-4DD1-A666-BFFC3ABED690}" type="datetimeFigureOut">
               <a:rPr lang="pt-BR" smtClean="0"/>
-              <a:t>08/06/2026</a:t>
+              <a:t>09/06/2026</a:t>
             </a:fld>
             <a:endParaRPr lang="pt-BR"/>
           </a:p>
@@ -4487,7 +4487,7 @@
           <a:p>
             <a:fld id="{7C8BC570-9881-4DD1-A666-BFFC3ABED690}" type="datetimeFigureOut">
               <a:rPr lang="pt-BR" smtClean="0"/>
-              <a:t>08/06/2026</a:t>
+              <a:t>09/06/2026</a:t>
             </a:fld>
             <a:endParaRPr lang="pt-BR"/>
           </a:p>
@@ -14137,10 +14137,10 @@
       </p:grpSpPr>
       <p:grpSp>
         <p:nvGrpSpPr>
-          <p:cNvPr id="12" name="Group 11">
+          <p:cNvPr id="7" name="Group 6">
             <a:extLst>
               <a:ext uri="{FF2B5EF4-FFF2-40B4-BE49-F238E27FC236}">
-                <a16:creationId xmlns:a16="http://schemas.microsoft.com/office/drawing/2014/main" id="{85203010-2883-0EA3-11F8-BF1A310C001F}"/>
+                <a16:creationId xmlns:a16="http://schemas.microsoft.com/office/drawing/2014/main" id="{4C164737-1DF1-7A94-0820-4540B763E114}"/>
               </a:ext>
             </a:extLst>
           </p:cNvPr>
@@ -14149,18 +14149,18 @@
         </p:nvGrpSpPr>
         <p:grpSpPr>
           <a:xfrm>
-            <a:off x="227779" y="647925"/>
-            <a:ext cx="11736438" cy="2486372"/>
-            <a:chOff x="227781" y="836344"/>
-            <a:chExt cx="11736438" cy="2486372"/>
+            <a:off x="161798" y="3862328"/>
+            <a:ext cx="11809618" cy="2486372"/>
+            <a:chOff x="161798" y="3862328"/>
+            <a:chExt cx="11809618" cy="2486372"/>
           </a:xfrm>
         </p:grpSpPr>
         <p:pic>
           <p:nvPicPr>
-            <p:cNvPr id="8" name="Picture 7">
+            <p:cNvPr id="5" name="Picture 4">
               <a:extLst>
                 <a:ext uri="{FF2B5EF4-FFF2-40B4-BE49-F238E27FC236}">
-                  <a16:creationId xmlns:a16="http://schemas.microsoft.com/office/drawing/2014/main" id="{EFBE7FAC-610B-1530-2035-4D46E6943DF8}"/>
+                  <a16:creationId xmlns:a16="http://schemas.microsoft.com/office/drawing/2014/main" id="{41B43844-CC90-5180-75F0-4AA34409EBA4}"/>
                 </a:ext>
               </a:extLst>
             </p:cNvPr>
@@ -14177,70 +14177,19 @@
                 </a:ext>
               </a:extLst>
             </a:blip>
-            <a:srcRect/>
+            <a:srcRect t="643" b="643"/>
             <a:stretch/>
           </p:blipFill>
           <p:spPr>
             <a:xfrm>
-              <a:off x="227781" y="836344"/>
-              <a:ext cx="11736438" cy="2486372"/>
+              <a:off x="6103208" y="3862333"/>
+              <a:ext cx="5868208" cy="2486367"/>
             </a:xfrm>
             <a:prstGeom prst="rect">
               <a:avLst/>
             </a:prstGeom>
           </p:spPr>
         </p:pic>
-        <p:pic>
-          <p:nvPicPr>
-            <p:cNvPr id="9" name="Picture 8">
-              <a:extLst>
-                <a:ext uri="{FF2B5EF4-FFF2-40B4-BE49-F238E27FC236}">
-                  <a16:creationId xmlns:a16="http://schemas.microsoft.com/office/drawing/2014/main" id="{8AA6569C-9CD9-988C-8062-8C4D6AB049BA}"/>
-                </a:ext>
-              </a:extLst>
-            </p:cNvPr>
-            <p:cNvPicPr>
-              <a:picLocks noChangeAspect="1"/>
-            </p:cNvPicPr>
-            <p:nvPr/>
-          </p:nvPicPr>
-          <p:blipFill>
-            <a:blip r:embed="rId3"/>
-            <a:stretch>
-              <a:fillRect/>
-            </a:stretch>
-          </p:blipFill>
-          <p:spPr>
-            <a:xfrm>
-              <a:off x="5803233" y="836344"/>
-              <a:ext cx="585531" cy="452810"/>
-            </a:xfrm>
-            <a:prstGeom prst="rect">
-              <a:avLst/>
-            </a:prstGeom>
-          </p:spPr>
-        </p:pic>
-      </p:grpSp>
-      <p:grpSp>
-        <p:nvGrpSpPr>
-          <p:cNvPr id="11" name="Group 10">
-            <a:extLst>
-              <a:ext uri="{FF2B5EF4-FFF2-40B4-BE49-F238E27FC236}">
-                <a16:creationId xmlns:a16="http://schemas.microsoft.com/office/drawing/2014/main" id="{D8F3B639-7391-F016-A4C3-A5944C193FEE}"/>
-              </a:ext>
-            </a:extLst>
-          </p:cNvPr>
-          <p:cNvGrpSpPr/>
-          <p:nvPr/>
-        </p:nvGrpSpPr>
-        <p:grpSpPr>
-          <a:xfrm>
-            <a:off x="227781" y="3924673"/>
-            <a:ext cx="11736438" cy="2486372"/>
-            <a:chOff x="227781" y="3984633"/>
-            <a:chExt cx="11736438" cy="2486372"/>
-          </a:xfrm>
-        </p:grpSpPr>
         <p:pic>
           <p:nvPicPr>
             <p:cNvPr id="3" name="Picture 2">
@@ -14256,45 +14205,20 @@
             <p:nvPr/>
           </p:nvPicPr>
           <p:blipFill>
-            <a:blip r:embed="rId4"/>
-            <a:stretch>
-              <a:fillRect/>
-            </a:stretch>
+            <a:blip r:embed="rId3">
+              <a:extLst>
+                <a:ext uri="{28A0092B-C50C-407E-A947-70E740481C1C}">
+                  <a14:useLocalDpi xmlns:a14="http://schemas.microsoft.com/office/drawing/2010/main" val="0"/>
+                </a:ext>
+              </a:extLst>
+            </a:blip>
+            <a:srcRect l="830" r="830"/>
+            <a:stretch/>
           </p:blipFill>
           <p:spPr>
             <a:xfrm>
-              <a:off x="227781" y="3984633"/>
-              <a:ext cx="11736438" cy="2486372"/>
-            </a:xfrm>
-            <a:prstGeom prst="rect">
-              <a:avLst/>
-            </a:prstGeom>
-          </p:spPr>
-        </p:pic>
-        <p:pic>
-          <p:nvPicPr>
-            <p:cNvPr id="10" name="Picture 9">
-              <a:extLst>
-                <a:ext uri="{FF2B5EF4-FFF2-40B4-BE49-F238E27FC236}">
-                  <a16:creationId xmlns:a16="http://schemas.microsoft.com/office/drawing/2014/main" id="{5FEA047C-452E-44BC-5272-4AFCD06558D4}"/>
-                </a:ext>
-              </a:extLst>
-            </p:cNvPr>
-            <p:cNvPicPr>
-              <a:picLocks noChangeAspect="1"/>
-            </p:cNvPicPr>
-            <p:nvPr/>
-          </p:nvPicPr>
-          <p:blipFill>
-            <a:blip r:embed="rId3"/>
-            <a:stretch>
-              <a:fillRect/>
-            </a:stretch>
-          </p:blipFill>
-          <p:spPr>
-            <a:xfrm>
-              <a:off x="5803233" y="3984633"/>
-              <a:ext cx="585531" cy="452810"/>
+              <a:off x="161798" y="3862328"/>
+              <a:ext cx="5868219" cy="2486372"/>
             </a:xfrm>
             <a:prstGeom prst="rect">
               <a:avLst/>
@@ -14372,6 +14296,97 @@
           </a:p>
         </p:txBody>
       </p:sp>
+      <p:grpSp>
+        <p:nvGrpSpPr>
+          <p:cNvPr id="13" name="Group 12">
+            <a:extLst>
+              <a:ext uri="{FF2B5EF4-FFF2-40B4-BE49-F238E27FC236}">
+                <a16:creationId xmlns:a16="http://schemas.microsoft.com/office/drawing/2014/main" id="{35685DFB-180C-F4C8-81BC-2CF5A19D58AE}"/>
+              </a:ext>
+            </a:extLst>
+          </p:cNvPr>
+          <p:cNvGrpSpPr/>
+          <p:nvPr/>
+        </p:nvGrpSpPr>
+        <p:grpSpPr>
+          <a:xfrm>
+            <a:off x="125208" y="642606"/>
+            <a:ext cx="11809618" cy="2486372"/>
+            <a:chOff x="161798" y="3862328"/>
+            <a:chExt cx="11809618" cy="2486372"/>
+          </a:xfrm>
+        </p:grpSpPr>
+        <p:pic>
+          <p:nvPicPr>
+            <p:cNvPr id="14" name="Picture 13">
+              <a:extLst>
+                <a:ext uri="{FF2B5EF4-FFF2-40B4-BE49-F238E27FC236}">
+                  <a16:creationId xmlns:a16="http://schemas.microsoft.com/office/drawing/2014/main" id="{DC636D5A-6215-6615-0528-B2D56106ABE4}"/>
+                </a:ext>
+              </a:extLst>
+            </p:cNvPr>
+            <p:cNvPicPr>
+              <a:picLocks noChangeAspect="1"/>
+            </p:cNvPicPr>
+            <p:nvPr/>
+          </p:nvPicPr>
+          <p:blipFill>
+            <a:blip r:embed="rId4">
+              <a:extLst>
+                <a:ext uri="{28A0092B-C50C-407E-A947-70E740481C1C}">
+                  <a14:useLocalDpi xmlns:a14="http://schemas.microsoft.com/office/drawing/2010/main" val="0"/>
+                </a:ext>
+              </a:extLst>
+            </a:blip>
+            <a:srcRect l="1494" r="1494"/>
+            <a:stretch/>
+          </p:blipFill>
+          <p:spPr>
+            <a:xfrm>
+              <a:off x="6103208" y="3862333"/>
+              <a:ext cx="5868208" cy="2486367"/>
+            </a:xfrm>
+            <a:prstGeom prst="rect">
+              <a:avLst/>
+            </a:prstGeom>
+          </p:spPr>
+        </p:pic>
+        <p:pic>
+          <p:nvPicPr>
+            <p:cNvPr id="15" name="Picture 14">
+              <a:extLst>
+                <a:ext uri="{FF2B5EF4-FFF2-40B4-BE49-F238E27FC236}">
+                  <a16:creationId xmlns:a16="http://schemas.microsoft.com/office/drawing/2014/main" id="{412B12D2-0216-833A-DD38-396C88BDFA53}"/>
+                </a:ext>
+              </a:extLst>
+            </p:cNvPr>
+            <p:cNvPicPr>
+              <a:picLocks noChangeAspect="1"/>
+            </p:cNvPicPr>
+            <p:nvPr/>
+          </p:nvPicPr>
+          <p:blipFill>
+            <a:blip r:embed="rId5">
+              <a:extLst>
+                <a:ext uri="{28A0092B-C50C-407E-A947-70E740481C1C}">
+                  <a14:useLocalDpi xmlns:a14="http://schemas.microsoft.com/office/drawing/2010/main" val="0"/>
+                </a:ext>
+              </a:extLst>
+            </a:blip>
+            <a:srcRect l="1587" r="1587"/>
+            <a:stretch/>
+          </p:blipFill>
+          <p:spPr>
+            <a:xfrm>
+              <a:off x="161798" y="3862328"/>
+              <a:ext cx="5868219" cy="2486372"/>
+            </a:xfrm>
+            <a:prstGeom prst="rect">
+              <a:avLst/>
+            </a:prstGeom>
+          </p:spPr>
+        </p:pic>
+      </p:grpSp>
     </p:spTree>
     <p:extLst>
       <p:ext uri="{BB962C8B-B14F-4D97-AF65-F5344CB8AC3E}">

</xml_diff>

<commit_message>
adding figures replan smooth
</commit_message>
<xml_diff>
--- a/DISSERTACAO/figuras/figures.pptx
+++ b/DISSERTACAO/figuras/figures.pptx
@@ -14550,6 +14550,132 @@
           </a:p>
         </p:txBody>
       </p:sp>
+      <p:grpSp>
+        <p:nvGrpSpPr>
+          <p:cNvPr id="6" name="Group 5">
+            <a:extLst>
+              <a:ext uri="{FF2B5EF4-FFF2-40B4-BE49-F238E27FC236}">
+                <a16:creationId xmlns:a16="http://schemas.microsoft.com/office/drawing/2014/main" id="{C466ADCD-E9DF-25E3-58B7-9D728374581B}"/>
+              </a:ext>
+            </a:extLst>
+          </p:cNvPr>
+          <p:cNvGrpSpPr/>
+          <p:nvPr/>
+        </p:nvGrpSpPr>
+        <p:grpSpPr>
+          <a:xfrm>
+            <a:off x="191191" y="3939778"/>
+            <a:ext cx="11809618" cy="2486372"/>
+            <a:chOff x="161798" y="3862328"/>
+            <a:chExt cx="11809618" cy="2486372"/>
+          </a:xfrm>
+        </p:grpSpPr>
+        <p:pic>
+          <p:nvPicPr>
+            <p:cNvPr id="8" name="Picture 7">
+              <a:extLst>
+                <a:ext uri="{FF2B5EF4-FFF2-40B4-BE49-F238E27FC236}">
+                  <a16:creationId xmlns:a16="http://schemas.microsoft.com/office/drawing/2014/main" id="{07527855-073A-6FE1-41FB-61C5B6045AA1}"/>
+                </a:ext>
+              </a:extLst>
+            </p:cNvPr>
+            <p:cNvPicPr>
+              <a:picLocks noChangeAspect="1"/>
+            </p:cNvPicPr>
+            <p:nvPr/>
+          </p:nvPicPr>
+          <p:blipFill>
+            <a:blip r:embed="rId4">
+              <a:extLst>
+                <a:ext uri="{28A0092B-C50C-407E-A947-70E740481C1C}">
+                  <a14:useLocalDpi xmlns:a14="http://schemas.microsoft.com/office/drawing/2010/main" val="0"/>
+                </a:ext>
+              </a:extLst>
+            </a:blip>
+            <a:srcRect t="227" b="227"/>
+            <a:stretch/>
+          </p:blipFill>
+          <p:spPr>
+            <a:xfrm>
+              <a:off x="6103208" y="3862333"/>
+              <a:ext cx="5868208" cy="2486367"/>
+            </a:xfrm>
+            <a:prstGeom prst="rect">
+              <a:avLst/>
+            </a:prstGeom>
+          </p:spPr>
+        </p:pic>
+        <p:pic>
+          <p:nvPicPr>
+            <p:cNvPr id="9" name="Picture 8">
+              <a:extLst>
+                <a:ext uri="{FF2B5EF4-FFF2-40B4-BE49-F238E27FC236}">
+                  <a16:creationId xmlns:a16="http://schemas.microsoft.com/office/drawing/2014/main" id="{6B83EF3A-2BD0-6A1F-7FFC-429399F0A620}"/>
+                </a:ext>
+              </a:extLst>
+            </p:cNvPr>
+            <p:cNvPicPr>
+              <a:picLocks noChangeAspect="1"/>
+            </p:cNvPicPr>
+            <p:nvPr/>
+          </p:nvPicPr>
+          <p:blipFill>
+            <a:blip r:embed="rId5">
+              <a:extLst>
+                <a:ext uri="{28A0092B-C50C-407E-A947-70E740481C1C}">
+                  <a14:useLocalDpi xmlns:a14="http://schemas.microsoft.com/office/drawing/2010/main" val="0"/>
+                </a:ext>
+              </a:extLst>
+            </a:blip>
+            <a:srcRect l="1559" r="1559"/>
+            <a:stretch/>
+          </p:blipFill>
+          <p:spPr>
+            <a:xfrm>
+              <a:off x="161798" y="3862328"/>
+              <a:ext cx="5868219" cy="2486372"/>
+            </a:xfrm>
+            <a:prstGeom prst="rect">
+              <a:avLst/>
+            </a:prstGeom>
+          </p:spPr>
+        </p:pic>
+      </p:grpSp>
+      <p:sp>
+        <p:nvSpPr>
+          <p:cNvPr id="10" name="TextBox 9">
+            <a:extLst>
+              <a:ext uri="{FF2B5EF4-FFF2-40B4-BE49-F238E27FC236}">
+                <a16:creationId xmlns:a16="http://schemas.microsoft.com/office/drawing/2014/main" id="{757C7332-32E6-1C8C-C7B4-288DD4A21447}"/>
+              </a:ext>
+            </a:extLst>
+          </p:cNvPr>
+          <p:cNvSpPr txBox="1"/>
+          <p:nvPr/>
+        </p:nvSpPr>
+        <p:spPr>
+          <a:xfrm>
+            <a:off x="4429465" y="3570446"/>
+            <a:ext cx="3406253" cy="369332"/>
+          </a:xfrm>
+          <a:prstGeom prst="rect">
+            <a:avLst/>
+          </a:prstGeom>
+          <a:noFill/>
+        </p:spPr>
+        <p:txBody>
+          <a:bodyPr wrap="none" rtlCol="0">
+            <a:spAutoFit/>
+          </a:bodyPr>
+          <a:lstStyle/>
+          <a:p>
+            <a:r>
+              <a:rPr lang="pt-BR" dirty="0"/>
+              <a:t>Resultados com Suavização 1E4</a:t>
+            </a:r>
+          </a:p>
+        </p:txBody>
+      </p:sp>
     </p:spTree>
     <p:extLst>
       <p:ext uri="{BB962C8B-B14F-4D97-AF65-F5344CB8AC3E}">

</xml_diff>